<commit_message>
Doc : add documentation
</commit_message>
<xml_diff>
--- a/docs/Atelier_Pratique_Pipeline_STM32Cube_improved.pptx
+++ b/docs/Atelier_Pratique_Pipeline_STM32Cube_improved.pptx
@@ -210,15 +210,38 @@
 </p:presentation>
 </file>
 
+<file path=ppt/revisionInfo.xml><?xml version="1.0" encoding="utf-8"?>
+<p1510:revInfo xmlns:a="http://schemas.openxmlformats.org/drawingml/2006/main" xmlns:r="http://schemas.openxmlformats.org/officeDocument/2006/relationships" xmlns:p1510="http://schemas.microsoft.com/office/powerpoint/2015/10/main">
+  <p1510:revLst>
+    <p1510:client id="{82EE7518-C9DF-45A4-9DE3-16FC3F3776E4}" v="3" dt="2026-07-06T14:26:52.895"/>
+  </p1510:revLst>
+</p1510:revInfo>
+</file>
+
 <file path=ppt/changesInfos/changesInfo1.xml><?xml version="1.0" encoding="utf-8"?>
 <pc:chgInfo xmlns:a="http://schemas.openxmlformats.org/drawingml/2006/main" xmlns:r="http://schemas.openxmlformats.org/officeDocument/2006/relationships" xmlns:ac="http://schemas.microsoft.com/office/drawing/2013/main/command" xmlns:pc="http://schemas.microsoft.com/office/powerpoint/2013/main/command">
   <pc:docChgLst>
     <pc:chgData name="Abir GHARBI" userId="ef92528f-00ab-4d87-966c-386bca485bd0" providerId="ADAL" clId="{F3D16DED-CAA7-4BF5-81E4-89DEDE7057F7}"/>
     <pc:docChg chg="undo custSel modSld">
-      <pc:chgData name="Abir GHARBI" userId="ef92528f-00ab-4d87-966c-386bca485bd0" providerId="ADAL" clId="{F3D16DED-CAA7-4BF5-81E4-89DEDE7057F7}" dt="2026-07-03T10:31:52.919" v="132" actId="27636"/>
+      <pc:chgData name="Abir GHARBI" userId="ef92528f-00ab-4d87-966c-386bca485bd0" providerId="ADAL" clId="{F3D16DED-CAA7-4BF5-81E4-89DEDE7057F7}" dt="2026-07-06T14:26:52.894" v="179"/>
       <pc:docMkLst>
         <pc:docMk/>
       </pc:docMkLst>
+      <pc:sldChg chg="modSp mod">
+        <pc:chgData name="Abir GHARBI" userId="ef92528f-00ab-4d87-966c-386bca485bd0" providerId="ADAL" clId="{F3D16DED-CAA7-4BF5-81E4-89DEDE7057F7}" dt="2026-07-06T13:15:31.374" v="155"/>
+        <pc:sldMkLst>
+          <pc:docMk/>
+          <pc:sldMk cId="0" sldId="257"/>
+        </pc:sldMkLst>
+        <pc:spChg chg="mod">
+          <ac:chgData name="Abir GHARBI" userId="ef92528f-00ab-4d87-966c-386bca485bd0" providerId="ADAL" clId="{F3D16DED-CAA7-4BF5-81E4-89DEDE7057F7}" dt="2026-07-06T13:15:31.374" v="155"/>
+          <ac:spMkLst>
+            <pc:docMk/>
+            <pc:sldMk cId="0" sldId="257"/>
+            <ac:spMk id="3" creationId="{00000000-0000-0000-0000-000000000000}"/>
+          </ac:spMkLst>
+        </pc:spChg>
+      </pc:sldChg>
       <pc:sldChg chg="modSp mod">
         <pc:chgData name="Abir GHARBI" userId="ef92528f-00ab-4d87-966c-386bca485bd0" providerId="ADAL" clId="{F3D16DED-CAA7-4BF5-81E4-89DEDE7057F7}" dt="2026-07-01T13:21:58.761" v="1" actId="20577"/>
         <pc:sldMkLst>
@@ -265,11 +288,90 @@
         </pc:spChg>
       </pc:sldChg>
       <pc:sldChg chg="modSp mod">
-        <pc:chgData name="Abir GHARBI" userId="ef92528f-00ab-4d87-966c-386bca485bd0" providerId="ADAL" clId="{F3D16DED-CAA7-4BF5-81E4-89DEDE7057F7}" dt="2026-07-03T10:31:52.919" v="132" actId="27636"/>
+        <pc:chgData name="Abir GHARBI" userId="ef92528f-00ab-4d87-966c-386bca485bd0" providerId="ADAL" clId="{F3D16DED-CAA7-4BF5-81E4-89DEDE7057F7}" dt="2026-07-06T13:15:31.500" v="173" actId="27636"/>
+        <pc:sldMkLst>
+          <pc:docMk/>
+          <pc:sldMk cId="0" sldId="335"/>
+        </pc:sldMkLst>
+        <pc:spChg chg="mod">
+          <ac:chgData name="Abir GHARBI" userId="ef92528f-00ab-4d87-966c-386bca485bd0" providerId="ADAL" clId="{F3D16DED-CAA7-4BF5-81E4-89DEDE7057F7}" dt="2026-07-06T13:15:31.500" v="173" actId="27636"/>
+          <ac:spMkLst>
+            <pc:docMk/>
+            <pc:sldMk cId="0" sldId="335"/>
+            <ac:spMk id="2" creationId="{00000000-0000-0000-0000-000000000000}"/>
+          </ac:spMkLst>
+        </pc:spChg>
+        <pc:spChg chg="mod">
+          <ac:chgData name="Abir GHARBI" userId="ef92528f-00ab-4d87-966c-386bca485bd0" providerId="ADAL" clId="{F3D16DED-CAA7-4BF5-81E4-89DEDE7057F7}" dt="2026-07-06T13:15:31.477" v="166" actId="27636"/>
+          <ac:spMkLst>
+            <pc:docMk/>
+            <pc:sldMk cId="0" sldId="335"/>
+            <ac:spMk id="4" creationId="{00000000-0000-0000-0000-000000000000}"/>
+          </ac:spMkLst>
+        </pc:spChg>
+        <pc:spChg chg="mod">
+          <ac:chgData name="Abir GHARBI" userId="ef92528f-00ab-4d87-966c-386bca485bd0" providerId="ADAL" clId="{F3D16DED-CAA7-4BF5-81E4-89DEDE7057F7}" dt="2026-07-06T13:15:31.491" v="170" actId="27636"/>
+          <ac:spMkLst>
+            <pc:docMk/>
+            <pc:sldMk cId="0" sldId="335"/>
+            <ac:spMk id="7" creationId="{00000000-0000-0000-0000-000000000000}"/>
+          </ac:spMkLst>
+        </pc:spChg>
+        <pc:spChg chg="mod">
+          <ac:chgData name="Abir GHARBI" userId="ef92528f-00ab-4d87-966c-386bca485bd0" providerId="ADAL" clId="{F3D16DED-CAA7-4BF5-81E4-89DEDE7057F7}" dt="2026-07-06T13:15:31.488" v="169" actId="27636"/>
+          <ac:spMkLst>
+            <pc:docMk/>
+            <pc:sldMk cId="0" sldId="335"/>
+            <ac:spMk id="8" creationId="{00000000-0000-0000-0000-000000000000}"/>
+          </ac:spMkLst>
+        </pc:spChg>
+        <pc:spChg chg="mod">
+          <ac:chgData name="Abir GHARBI" userId="ef92528f-00ab-4d87-966c-386bca485bd0" providerId="ADAL" clId="{F3D16DED-CAA7-4BF5-81E4-89DEDE7057F7}" dt="2026-07-06T13:15:31.493" v="171" actId="27636"/>
+          <ac:spMkLst>
+            <pc:docMk/>
+            <pc:sldMk cId="0" sldId="335"/>
+            <ac:spMk id="11" creationId="{00000000-0000-0000-0000-000000000000}"/>
+          </ac:spMkLst>
+        </pc:spChg>
+        <pc:spChg chg="mod">
+          <ac:chgData name="Abir GHARBI" userId="ef92528f-00ab-4d87-966c-386bca485bd0" providerId="ADAL" clId="{F3D16DED-CAA7-4BF5-81E4-89DEDE7057F7}" dt="2026-07-06T13:15:31.480" v="167" actId="27636"/>
+          <ac:spMkLst>
+            <pc:docMk/>
+            <pc:sldMk cId="0" sldId="335"/>
+            <ac:spMk id="12" creationId="{00000000-0000-0000-0000-000000000000}"/>
+          </ac:spMkLst>
+        </pc:spChg>
+        <pc:spChg chg="mod">
+          <ac:chgData name="Abir GHARBI" userId="ef92528f-00ab-4d87-966c-386bca485bd0" providerId="ADAL" clId="{F3D16DED-CAA7-4BF5-81E4-89DEDE7057F7}" dt="2026-07-06T13:15:31.497" v="172" actId="27636"/>
+          <ac:spMkLst>
+            <pc:docMk/>
+            <pc:sldMk cId="0" sldId="335"/>
+            <ac:spMk id="15" creationId="{00000000-0000-0000-0000-000000000000}"/>
+          </ac:spMkLst>
+        </pc:spChg>
+        <pc:spChg chg="mod">
+          <ac:chgData name="Abir GHARBI" userId="ef92528f-00ab-4d87-966c-386bca485bd0" providerId="ADAL" clId="{F3D16DED-CAA7-4BF5-81E4-89DEDE7057F7}" dt="2026-07-06T13:15:31.485" v="168" actId="27636"/>
+          <ac:spMkLst>
+            <pc:docMk/>
+            <pc:sldMk cId="0" sldId="335"/>
+            <ac:spMk id="18" creationId="{00000000-0000-0000-0000-000000000000}"/>
+          </ac:spMkLst>
+        </pc:spChg>
+      </pc:sldChg>
+      <pc:sldChg chg="modSp mod">
+        <pc:chgData name="Abir GHARBI" userId="ef92528f-00ab-4d87-966c-386bca485bd0" providerId="ADAL" clId="{F3D16DED-CAA7-4BF5-81E4-89DEDE7057F7}" dt="2026-07-06T13:15:31.467" v="165" actId="27636"/>
         <pc:sldMkLst>
           <pc:docMk/>
           <pc:sldMk cId="0" sldId="336"/>
         </pc:sldMkLst>
+        <pc:spChg chg="mod">
+          <ac:chgData name="Abir GHARBI" userId="ef92528f-00ab-4d87-966c-386bca485bd0" providerId="ADAL" clId="{F3D16DED-CAA7-4BF5-81E4-89DEDE7057F7}" dt="2026-07-06T13:15:31.467" v="165" actId="27636"/>
+          <ac:spMkLst>
+            <pc:docMk/>
+            <pc:sldMk cId="0" sldId="336"/>
+            <ac:spMk id="2" creationId="{00000000-0000-0000-0000-000000000000}"/>
+          </ac:spMkLst>
+        </pc:spChg>
         <pc:spChg chg="mod">
           <ac:chgData name="Abir GHARBI" userId="ef92528f-00ab-4d87-966c-386bca485bd0" providerId="ADAL" clId="{F3D16DED-CAA7-4BF5-81E4-89DEDE7057F7}" dt="2026-07-03T10:31:52.816" v="125" actId="1076"/>
           <ac:spMkLst>
@@ -352,11 +454,19 @@
         </pc:cxnChg>
       </pc:sldChg>
       <pc:sldChg chg="modSp mod">
-        <pc:chgData name="Abir GHARBI" userId="ef92528f-00ab-4d87-966c-386bca485bd0" providerId="ADAL" clId="{F3D16DED-CAA7-4BF5-81E4-89DEDE7057F7}" dt="2026-07-03T10:31:41.008" v="124" actId="27636"/>
+        <pc:chgData name="Abir GHARBI" userId="ef92528f-00ab-4d87-966c-386bca485bd0" providerId="ADAL" clId="{F3D16DED-CAA7-4BF5-81E4-89DEDE7057F7}" dt="2026-07-06T13:15:31.458" v="164" actId="27636"/>
         <pc:sldMkLst>
           <pc:docMk/>
           <pc:sldMk cId="0" sldId="337"/>
         </pc:sldMkLst>
+        <pc:spChg chg="mod">
+          <ac:chgData name="Abir GHARBI" userId="ef92528f-00ab-4d87-966c-386bca485bd0" providerId="ADAL" clId="{F3D16DED-CAA7-4BF5-81E4-89DEDE7057F7}" dt="2026-07-06T13:15:31.458" v="164" actId="27636"/>
+          <ac:spMkLst>
+            <pc:docMk/>
+            <pc:sldMk cId="0" sldId="337"/>
+            <ac:spMk id="2" creationId="{00000000-0000-0000-0000-000000000000}"/>
+          </ac:spMkLst>
+        </pc:spChg>
         <pc:spChg chg="mod">
           <ac:chgData name="Abir GHARBI" userId="ef92528f-00ab-4d87-966c-386bca485bd0" providerId="ADAL" clId="{F3D16DED-CAA7-4BF5-81E4-89DEDE7057F7}" dt="2026-07-03T10:31:40.968" v="120" actId="27636"/>
           <ac:spMkLst>
@@ -495,11 +605,19 @@
         </pc:spChg>
       </pc:sldChg>
       <pc:sldChg chg="modSp mod">
-        <pc:chgData name="Abir GHARBI" userId="ef92528f-00ab-4d87-966c-386bca485bd0" providerId="ADAL" clId="{F3D16DED-CAA7-4BF5-81E4-89DEDE7057F7}" dt="2026-07-03T10:30:43.970" v="112" actId="1076"/>
+        <pc:chgData name="Abir GHARBI" userId="ef92528f-00ab-4d87-966c-386bca485bd0" providerId="ADAL" clId="{F3D16DED-CAA7-4BF5-81E4-89DEDE7057F7}" dt="2026-07-06T13:15:31.444" v="163" actId="27636"/>
         <pc:sldMkLst>
           <pc:docMk/>
           <pc:sldMk cId="0" sldId="338"/>
         </pc:sldMkLst>
+        <pc:spChg chg="mod">
+          <ac:chgData name="Abir GHARBI" userId="ef92528f-00ab-4d87-966c-386bca485bd0" providerId="ADAL" clId="{F3D16DED-CAA7-4BF5-81E4-89DEDE7057F7}" dt="2026-07-06T13:15:31.444" v="163" actId="27636"/>
+          <ac:spMkLst>
+            <pc:docMk/>
+            <pc:sldMk cId="0" sldId="338"/>
+            <ac:spMk id="2" creationId="{00000000-0000-0000-0000-000000000000}"/>
+          </ac:spMkLst>
+        </pc:spChg>
         <pc:spChg chg="mod">
           <ac:chgData name="Abir GHARBI" userId="ef92528f-00ab-4d87-966c-386bca485bd0" providerId="ADAL" clId="{F3D16DED-CAA7-4BF5-81E4-89DEDE7057F7}" dt="2026-07-03T10:30:43.970" v="112" actId="1076"/>
           <ac:spMkLst>
@@ -750,11 +868,19 @@
         </pc:cxnChg>
       </pc:sldChg>
       <pc:sldChg chg="modSp mod">
-        <pc:chgData name="Abir GHARBI" userId="ef92528f-00ab-4d87-966c-386bca485bd0" providerId="ADAL" clId="{F3D16DED-CAA7-4BF5-81E4-89DEDE7057F7}" dt="2026-07-03T10:30:01.289" v="110" actId="1076"/>
+        <pc:chgData name="Abir GHARBI" userId="ef92528f-00ab-4d87-966c-386bca485bd0" providerId="ADAL" clId="{F3D16DED-CAA7-4BF5-81E4-89DEDE7057F7}" dt="2026-07-06T13:15:31.435" v="162" actId="27636"/>
         <pc:sldMkLst>
           <pc:docMk/>
           <pc:sldMk cId="0" sldId="339"/>
         </pc:sldMkLst>
+        <pc:spChg chg="mod">
+          <ac:chgData name="Abir GHARBI" userId="ef92528f-00ab-4d87-966c-386bca485bd0" providerId="ADAL" clId="{F3D16DED-CAA7-4BF5-81E4-89DEDE7057F7}" dt="2026-07-06T13:15:31.435" v="162" actId="27636"/>
+          <ac:spMkLst>
+            <pc:docMk/>
+            <pc:sldMk cId="0" sldId="339"/>
+            <ac:spMk id="2" creationId="{00000000-0000-0000-0000-000000000000}"/>
+          </ac:spMkLst>
+        </pc:spChg>
         <pc:spChg chg="mod">
           <ac:chgData name="Abir GHARBI" userId="ef92528f-00ab-4d87-966c-386bca485bd0" providerId="ADAL" clId="{F3D16DED-CAA7-4BF5-81E4-89DEDE7057F7}" dt="2026-07-03T10:30:01.289" v="110" actId="1076"/>
           <ac:spMkLst>
@@ -868,6 +994,205 @@
           </ac:spMkLst>
         </pc:spChg>
       </pc:sldChg>
+      <pc:sldChg chg="addSp delSp modSp mod">
+        <pc:chgData name="Abir GHARBI" userId="ef92528f-00ab-4d87-966c-386bca485bd0" providerId="ADAL" clId="{F3D16DED-CAA7-4BF5-81E4-89DEDE7057F7}" dt="2026-07-06T14:26:52.894" v="179"/>
+        <pc:sldMkLst>
+          <pc:docMk/>
+          <pc:sldMk cId="0" sldId="340"/>
+        </pc:sldMkLst>
+        <pc:spChg chg="mod">
+          <ac:chgData name="Abir GHARBI" userId="ef92528f-00ab-4d87-966c-386bca485bd0" providerId="ADAL" clId="{F3D16DED-CAA7-4BF5-81E4-89DEDE7057F7}" dt="2026-07-06T13:15:31.414" v="159" actId="27636"/>
+          <ac:spMkLst>
+            <pc:docMk/>
+            <pc:sldMk cId="0" sldId="340"/>
+            <ac:spMk id="2" creationId="{00000000-0000-0000-0000-000000000000}"/>
+          </ac:spMkLst>
+        </pc:spChg>
+        <pc:spChg chg="del mod">
+          <ac:chgData name="Abir GHARBI" userId="ef92528f-00ab-4d87-966c-386bca485bd0" providerId="ADAL" clId="{F3D16DED-CAA7-4BF5-81E4-89DEDE7057F7}" dt="2026-07-06T14:26:51.468" v="178" actId="21"/>
+          <ac:spMkLst>
+            <pc:docMk/>
+            <pc:sldMk cId="0" sldId="340"/>
+            <ac:spMk id="4" creationId="{00000000-0000-0000-0000-000000000000}"/>
+          </ac:spMkLst>
+        </pc:spChg>
+        <pc:spChg chg="del mod">
+          <ac:chgData name="Abir GHARBI" userId="ef92528f-00ab-4d87-966c-386bca485bd0" providerId="ADAL" clId="{F3D16DED-CAA7-4BF5-81E4-89DEDE7057F7}" dt="2026-07-06T14:26:51.468" v="178" actId="21"/>
+          <ac:spMkLst>
+            <pc:docMk/>
+            <pc:sldMk cId="0" sldId="340"/>
+            <ac:spMk id="5" creationId="{00000000-0000-0000-0000-000000000000}"/>
+          </ac:spMkLst>
+        </pc:spChg>
+        <pc:spChg chg="del">
+          <ac:chgData name="Abir GHARBI" userId="ef92528f-00ab-4d87-966c-386bca485bd0" providerId="ADAL" clId="{F3D16DED-CAA7-4BF5-81E4-89DEDE7057F7}" dt="2026-07-06T14:26:51.468" v="178" actId="21"/>
+          <ac:spMkLst>
+            <pc:docMk/>
+            <pc:sldMk cId="0" sldId="340"/>
+            <ac:spMk id="6" creationId="{00000000-0000-0000-0000-000000000000}"/>
+          </ac:spMkLst>
+        </pc:spChg>
+        <pc:spChg chg="del">
+          <ac:chgData name="Abir GHARBI" userId="ef92528f-00ab-4d87-966c-386bca485bd0" providerId="ADAL" clId="{F3D16DED-CAA7-4BF5-81E4-89DEDE7057F7}" dt="2026-07-06T14:26:51.468" v="178" actId="21"/>
+          <ac:spMkLst>
+            <pc:docMk/>
+            <pc:sldMk cId="0" sldId="340"/>
+            <ac:spMk id="7" creationId="{00000000-0000-0000-0000-000000000000}"/>
+          </ac:spMkLst>
+        </pc:spChg>
+        <pc:spChg chg="del">
+          <ac:chgData name="Abir GHARBI" userId="ef92528f-00ab-4d87-966c-386bca485bd0" providerId="ADAL" clId="{F3D16DED-CAA7-4BF5-81E4-89DEDE7057F7}" dt="2026-07-06T14:26:51.468" v="178" actId="21"/>
+          <ac:spMkLst>
+            <pc:docMk/>
+            <pc:sldMk cId="0" sldId="340"/>
+            <ac:spMk id="8" creationId="{00000000-0000-0000-0000-000000000000}"/>
+          </ac:spMkLst>
+        </pc:spChg>
+        <pc:spChg chg="del">
+          <ac:chgData name="Abir GHARBI" userId="ef92528f-00ab-4d87-966c-386bca485bd0" providerId="ADAL" clId="{F3D16DED-CAA7-4BF5-81E4-89DEDE7057F7}" dt="2026-07-06T14:26:51.468" v="178" actId="21"/>
+          <ac:spMkLst>
+            <pc:docMk/>
+            <pc:sldMk cId="0" sldId="340"/>
+            <ac:spMk id="9" creationId="{00000000-0000-0000-0000-000000000000}"/>
+          </ac:spMkLst>
+        </pc:spChg>
+        <pc:spChg chg="mod">
+          <ac:chgData name="Abir GHARBI" userId="ef92528f-00ab-4d87-966c-386bca485bd0" providerId="ADAL" clId="{F3D16DED-CAA7-4BF5-81E4-89DEDE7057F7}" dt="2026-07-06T13:15:31.406" v="156" actId="27636"/>
+          <ac:spMkLst>
+            <pc:docMk/>
+            <pc:sldMk cId="0" sldId="340"/>
+            <ac:spMk id="15" creationId="{00000000-0000-0000-0000-000000000000}"/>
+          </ac:spMkLst>
+        </pc:spChg>
+        <pc:spChg chg="mod">
+          <ac:chgData name="Abir GHARBI" userId="ef92528f-00ab-4d87-966c-386bca485bd0" providerId="ADAL" clId="{F3D16DED-CAA7-4BF5-81E4-89DEDE7057F7}" dt="2026-07-06T14:21:52.396" v="175" actId="27636"/>
+          <ac:spMkLst>
+            <pc:docMk/>
+            <pc:sldMk cId="0" sldId="340"/>
+            <ac:spMk id="16" creationId="{00000000-0000-0000-0000-000000000000}"/>
+          </ac:spMkLst>
+        </pc:spChg>
+        <pc:spChg chg="mod">
+          <ac:chgData name="Abir GHARBI" userId="ef92528f-00ab-4d87-966c-386bca485bd0" providerId="ADAL" clId="{F3D16DED-CAA7-4BF5-81E4-89DEDE7057F7}" dt="2026-07-06T14:22:02.509" v="177" actId="27636"/>
+          <ac:spMkLst>
+            <pc:docMk/>
+            <pc:sldMk cId="0" sldId="340"/>
+            <ac:spMk id="17" creationId="{00000000-0000-0000-0000-000000000000}"/>
+          </ac:spMkLst>
+        </pc:spChg>
+        <pc:spChg chg="add mod">
+          <ac:chgData name="Abir GHARBI" userId="ef92528f-00ab-4d87-966c-386bca485bd0" providerId="ADAL" clId="{F3D16DED-CAA7-4BF5-81E4-89DEDE7057F7}" dt="2026-07-06T14:26:52.894" v="179"/>
+          <ac:spMkLst>
+            <pc:docMk/>
+            <pc:sldMk cId="0" sldId="340"/>
+            <ac:spMk id="19" creationId="{00000000-0000-0000-0000-000000000000}"/>
+          </ac:spMkLst>
+        </pc:spChg>
+        <pc:spChg chg="add mod">
+          <ac:chgData name="Abir GHARBI" userId="ef92528f-00ab-4d87-966c-386bca485bd0" providerId="ADAL" clId="{F3D16DED-CAA7-4BF5-81E4-89DEDE7057F7}" dt="2026-07-06T14:26:52.894" v="179"/>
+          <ac:spMkLst>
+            <pc:docMk/>
+            <pc:sldMk cId="0" sldId="340"/>
+            <ac:spMk id="20" creationId="{00000000-0000-0000-0000-000000000000}"/>
+          </ac:spMkLst>
+        </pc:spChg>
+        <pc:spChg chg="add mod">
+          <ac:chgData name="Abir GHARBI" userId="ef92528f-00ab-4d87-966c-386bca485bd0" providerId="ADAL" clId="{F3D16DED-CAA7-4BF5-81E4-89DEDE7057F7}" dt="2026-07-06T14:26:52.894" v="179"/>
+          <ac:spMkLst>
+            <pc:docMk/>
+            <pc:sldMk cId="0" sldId="340"/>
+            <ac:spMk id="21" creationId="{00000000-0000-0000-0000-000000000000}"/>
+          </ac:spMkLst>
+        </pc:spChg>
+        <pc:spChg chg="add mod">
+          <ac:chgData name="Abir GHARBI" userId="ef92528f-00ab-4d87-966c-386bca485bd0" providerId="ADAL" clId="{F3D16DED-CAA7-4BF5-81E4-89DEDE7057F7}" dt="2026-07-06T14:26:52.894" v="179"/>
+          <ac:spMkLst>
+            <pc:docMk/>
+            <pc:sldMk cId="0" sldId="340"/>
+            <ac:spMk id="22" creationId="{00000000-0000-0000-0000-000000000000}"/>
+          </ac:spMkLst>
+        </pc:spChg>
+        <pc:spChg chg="add mod">
+          <ac:chgData name="Abir GHARBI" userId="ef92528f-00ab-4d87-966c-386bca485bd0" providerId="ADAL" clId="{F3D16DED-CAA7-4BF5-81E4-89DEDE7057F7}" dt="2026-07-06T14:26:52.894" v="179"/>
+          <ac:spMkLst>
+            <pc:docMk/>
+            <pc:sldMk cId="0" sldId="340"/>
+            <ac:spMk id="23" creationId="{00000000-0000-0000-0000-000000000000}"/>
+          </ac:spMkLst>
+        </pc:spChg>
+        <pc:spChg chg="add mod">
+          <ac:chgData name="Abir GHARBI" userId="ef92528f-00ab-4d87-966c-386bca485bd0" providerId="ADAL" clId="{F3D16DED-CAA7-4BF5-81E4-89DEDE7057F7}" dt="2026-07-06T14:26:52.894" v="179"/>
+          <ac:spMkLst>
+            <pc:docMk/>
+            <pc:sldMk cId="0" sldId="340"/>
+            <ac:spMk id="24" creationId="{00000000-0000-0000-0000-000000000000}"/>
+          </ac:spMkLst>
+        </pc:spChg>
+        <pc:cxnChg chg="del">
+          <ac:chgData name="Abir GHARBI" userId="ef92528f-00ab-4d87-966c-386bca485bd0" providerId="ADAL" clId="{F3D16DED-CAA7-4BF5-81E4-89DEDE7057F7}" dt="2026-07-06T14:26:51.468" v="178" actId="21"/>
+          <ac:cxnSpMkLst>
+            <pc:docMk/>
+            <pc:sldMk cId="0" sldId="340"/>
+            <ac:cxnSpMk id="11" creationId="{00000000-0000-0000-0000-000000000000}"/>
+          </ac:cxnSpMkLst>
+        </pc:cxnChg>
+        <pc:cxnChg chg="del">
+          <ac:chgData name="Abir GHARBI" userId="ef92528f-00ab-4d87-966c-386bca485bd0" providerId="ADAL" clId="{F3D16DED-CAA7-4BF5-81E4-89DEDE7057F7}" dt="2026-07-06T14:26:51.468" v="178" actId="21"/>
+          <ac:cxnSpMkLst>
+            <pc:docMk/>
+            <pc:sldMk cId="0" sldId="340"/>
+            <ac:cxnSpMk id="12" creationId="{00000000-0000-0000-0000-000000000000}"/>
+          </ac:cxnSpMkLst>
+        </pc:cxnChg>
+        <pc:cxnChg chg="del">
+          <ac:chgData name="Abir GHARBI" userId="ef92528f-00ab-4d87-966c-386bca485bd0" providerId="ADAL" clId="{F3D16DED-CAA7-4BF5-81E4-89DEDE7057F7}" dt="2026-07-06T14:26:51.468" v="178" actId="21"/>
+          <ac:cxnSpMkLst>
+            <pc:docMk/>
+            <pc:sldMk cId="0" sldId="340"/>
+            <ac:cxnSpMk id="13" creationId="{00000000-0000-0000-0000-000000000000}"/>
+          </ac:cxnSpMkLst>
+        </pc:cxnChg>
+        <pc:cxnChg chg="del">
+          <ac:chgData name="Abir GHARBI" userId="ef92528f-00ab-4d87-966c-386bca485bd0" providerId="ADAL" clId="{F3D16DED-CAA7-4BF5-81E4-89DEDE7057F7}" dt="2026-07-06T14:26:51.468" v="178" actId="21"/>
+          <ac:cxnSpMkLst>
+            <pc:docMk/>
+            <pc:sldMk cId="0" sldId="340"/>
+            <ac:cxnSpMk id="14" creationId="{00000000-0000-0000-0000-000000000000}"/>
+          </ac:cxnSpMkLst>
+        </pc:cxnChg>
+        <pc:cxnChg chg="add mod">
+          <ac:chgData name="Abir GHARBI" userId="ef92528f-00ab-4d87-966c-386bca485bd0" providerId="ADAL" clId="{F3D16DED-CAA7-4BF5-81E4-89DEDE7057F7}" dt="2026-07-06T14:26:52.894" v="179"/>
+          <ac:cxnSpMkLst>
+            <pc:docMk/>
+            <pc:sldMk cId="0" sldId="340"/>
+            <ac:cxnSpMk id="25" creationId="{00000000-0000-0000-0000-000000000000}"/>
+          </ac:cxnSpMkLst>
+        </pc:cxnChg>
+        <pc:cxnChg chg="add mod">
+          <ac:chgData name="Abir GHARBI" userId="ef92528f-00ab-4d87-966c-386bca485bd0" providerId="ADAL" clId="{F3D16DED-CAA7-4BF5-81E4-89DEDE7057F7}" dt="2026-07-06T14:26:52.894" v="179"/>
+          <ac:cxnSpMkLst>
+            <pc:docMk/>
+            <pc:sldMk cId="0" sldId="340"/>
+            <ac:cxnSpMk id="26" creationId="{00000000-0000-0000-0000-000000000000}"/>
+          </ac:cxnSpMkLst>
+        </pc:cxnChg>
+        <pc:cxnChg chg="add mod">
+          <ac:chgData name="Abir GHARBI" userId="ef92528f-00ab-4d87-966c-386bca485bd0" providerId="ADAL" clId="{F3D16DED-CAA7-4BF5-81E4-89DEDE7057F7}" dt="2026-07-06T14:26:52.894" v="179"/>
+          <ac:cxnSpMkLst>
+            <pc:docMk/>
+            <pc:sldMk cId="0" sldId="340"/>
+            <ac:cxnSpMk id="28" creationId="{00000000-0000-0000-0000-000000000000}"/>
+          </ac:cxnSpMkLst>
+        </pc:cxnChg>
+        <pc:cxnChg chg="add mod">
+          <ac:chgData name="Abir GHARBI" userId="ef92528f-00ab-4d87-966c-386bca485bd0" providerId="ADAL" clId="{F3D16DED-CAA7-4BF5-81E4-89DEDE7057F7}" dt="2026-07-06T14:26:52.894" v="179"/>
+          <ac:cxnSpMkLst>
+            <pc:docMk/>
+            <pc:sldMk cId="0" sldId="340"/>
+            <ac:cxnSpMk id="29" creationId="{00000000-0000-0000-0000-000000000000}"/>
+          </ac:cxnSpMkLst>
+        </pc:cxnChg>
+      </pc:sldChg>
     </pc:docChg>
   </pc:docChgLst>
 </pc:chgInfo>
@@ -955,7 +1280,7 @@
           <a:p>
             <a:fld id="{35722CAA-D3B9-4A8A-912A-C1AE79924BE1}" type="datetimeFigureOut">
               <a:rPr lang="en-US" smtClean="0"/>
-              <a:t>7/3/2026</a:t>
+              <a:t>7/6/2026</a:t>
             </a:fld>
             <a:endParaRPr lang="en-US"/>
           </a:p>
@@ -1611,7 +1936,7 @@
           <a:p>
             <a:fld id="{5BCAD085-E8A6-8845-BD4E-CB4CCA059FC4}" type="datetimeFigureOut">
               <a:rPr lang="en-US" smtClean="0"/>
-              <a:t>7/3/2026</a:t>
+              <a:t>7/6/2026</a:t>
             </a:fld>
             <a:endParaRPr lang="en-US"/>
           </a:p>
@@ -1779,7 +2104,7 @@
           <a:p>
             <a:fld id="{5BCAD085-E8A6-8845-BD4E-CB4CCA059FC4}" type="datetimeFigureOut">
               <a:rPr lang="en-US" smtClean="0"/>
-              <a:t>7/3/2026</a:t>
+              <a:t>7/6/2026</a:t>
             </a:fld>
             <a:endParaRPr lang="en-US"/>
           </a:p>
@@ -1957,7 +2282,7 @@
           <a:p>
             <a:fld id="{5BCAD085-E8A6-8845-BD4E-CB4CCA059FC4}" type="datetimeFigureOut">
               <a:rPr lang="en-US" smtClean="0"/>
-              <a:t>7/3/2026</a:t>
+              <a:t>7/6/2026</a:t>
             </a:fld>
             <a:endParaRPr lang="en-US"/>
           </a:p>
@@ -2125,7 +2450,7 @@
           <a:p>
             <a:fld id="{5BCAD085-E8A6-8845-BD4E-CB4CCA059FC4}" type="datetimeFigureOut">
               <a:rPr lang="en-US" smtClean="0"/>
-              <a:t>7/3/2026</a:t>
+              <a:t>7/6/2026</a:t>
             </a:fld>
             <a:endParaRPr lang="en-US"/>
           </a:p>
@@ -2370,7 +2695,7 @@
           <a:p>
             <a:fld id="{5BCAD085-E8A6-8845-BD4E-CB4CCA059FC4}" type="datetimeFigureOut">
               <a:rPr lang="en-US" smtClean="0"/>
-              <a:t>7/3/2026</a:t>
+              <a:t>7/6/2026</a:t>
             </a:fld>
             <a:endParaRPr lang="en-US"/>
           </a:p>
@@ -2655,7 +2980,7 @@
           <a:p>
             <a:fld id="{5BCAD085-E8A6-8845-BD4E-CB4CCA059FC4}" type="datetimeFigureOut">
               <a:rPr lang="en-US" smtClean="0"/>
-              <a:t>7/3/2026</a:t>
+              <a:t>7/6/2026</a:t>
             </a:fld>
             <a:endParaRPr lang="en-US"/>
           </a:p>
@@ -3074,7 +3399,7 @@
           <a:p>
             <a:fld id="{5BCAD085-E8A6-8845-BD4E-CB4CCA059FC4}" type="datetimeFigureOut">
               <a:rPr lang="en-US" smtClean="0"/>
-              <a:t>7/3/2026</a:t>
+              <a:t>7/6/2026</a:t>
             </a:fld>
             <a:endParaRPr lang="en-US"/>
           </a:p>
@@ -3191,7 +3516,7 @@
           <a:p>
             <a:fld id="{5BCAD085-E8A6-8845-BD4E-CB4CCA059FC4}" type="datetimeFigureOut">
               <a:rPr lang="en-US" smtClean="0"/>
-              <a:t>7/3/2026</a:t>
+              <a:t>7/6/2026</a:t>
             </a:fld>
             <a:endParaRPr lang="en-US"/>
           </a:p>
@@ -3286,7 +3611,7 @@
           <a:p>
             <a:fld id="{5BCAD085-E8A6-8845-BD4E-CB4CCA059FC4}" type="datetimeFigureOut">
               <a:rPr lang="en-US" smtClean="0"/>
-              <a:t>7/3/2026</a:t>
+              <a:t>7/6/2026</a:t>
             </a:fld>
             <a:endParaRPr lang="en-US"/>
           </a:p>
@@ -3561,7 +3886,7 @@
           <a:p>
             <a:fld id="{5BCAD085-E8A6-8845-BD4E-CB4CCA059FC4}" type="datetimeFigureOut">
               <a:rPr lang="en-US" smtClean="0"/>
-              <a:t>7/3/2026</a:t>
+              <a:t>7/6/2026</a:t>
             </a:fld>
             <a:endParaRPr lang="en-US"/>
           </a:p>
@@ -3813,7 +4138,7 @@
           <a:p>
             <a:fld id="{5BCAD085-E8A6-8845-BD4E-CB4CCA059FC4}" type="datetimeFigureOut">
               <a:rPr lang="en-US" smtClean="0"/>
-              <a:t>7/3/2026</a:t>
+              <a:t>7/6/2026</a:t>
             </a:fld>
             <a:endParaRPr lang="en-US"/>
           </a:p>
@@ -4024,7 +4349,7 @@
           <a:p>
             <a:fld id="{5BCAD085-E8A6-8845-BD4E-CB4CCA059FC4}" type="datetimeFigureOut">
               <a:rPr lang="en-US" smtClean="0"/>
-              <a:t>7/3/2026</a:t>
+              <a:t>7/6/2026</a:t>
             </a:fld>
             <a:endParaRPr lang="en-US"/>
           </a:p>
@@ -4501,7 +4826,7 @@
         </p:spPr>
         <p:txBody>
           <a:bodyPr wrap="square">
-            <a:normAutofit/>
+            <a:normAutofit fontScale="92500" lnSpcReduction="10000"/>
           </a:bodyPr>
           <a:lstStyle/>
           <a:p>
@@ -4555,7 +4880,283 @@
       </p:sp>
       <p:sp>
         <p:nvSpPr>
-          <p:cNvPr id="4" name="Rounded Rectangle 3"/>
+          <p:cNvPr id="15" name="TextBox 14"/>
+          <p:cNvSpPr txBox="1"/>
+          <p:nvPr/>
+        </p:nvSpPr>
+        <p:spPr>
+          <a:xfrm>
+            <a:off x="432000" y="1835999"/>
+            <a:ext cx="8100000" cy="288000"/>
+          </a:xfrm>
+          <a:prstGeom prst="rect">
+            <a:avLst/>
+          </a:prstGeom>
+          <a:noFill/>
+        </p:spPr>
+        <p:txBody>
+          <a:bodyPr wrap="square">
+            <a:normAutofit fontScale="92500" lnSpcReduction="20000"/>
+          </a:bodyPr>
+          <a:lstStyle/>
+          <a:p>
+            <a:pPr algn="l">
+              <a:defRPr sz="1600" b="1">
+                <a:solidFill>
+                  <a:srgbClr val="1A237E"/>
+                </a:solidFill>
+              </a:defRPr>
+            </a:pPr>
+            <a:r>
+              <a:t>What the audience must understand first</a:t>
+            </a:r>
+          </a:p>
+        </p:txBody>
+      </p:sp>
+      <p:sp>
+        <p:nvSpPr>
+          <p:cNvPr id="16" name="Rounded Rectangle 15"/>
+          <p:cNvSpPr/>
+          <p:nvPr/>
+        </p:nvSpPr>
+        <p:spPr>
+          <a:xfrm>
+            <a:off x="432000" y="2196000"/>
+            <a:ext cx="2376000" cy="756000"/>
+          </a:xfrm>
+          <a:prstGeom prst="roundRect">
+            <a:avLst/>
+          </a:prstGeom>
+          <a:solidFill>
+            <a:srgbClr val="F5F7FA"/>
+          </a:solidFill>
+          <a:ln w="15240">
+            <a:solidFill>
+              <a:srgbClr val="5C6069"/>
+            </a:solidFill>
+          </a:ln>
+        </p:spPr>
+        <p:style>
+          <a:lnRef idx="1">
+            <a:schemeClr val="accent1"/>
+          </a:lnRef>
+          <a:fillRef idx="3">
+            <a:schemeClr val="accent1"/>
+          </a:fillRef>
+          <a:effectRef idx="2">
+            <a:schemeClr val="accent1"/>
+          </a:effectRef>
+          <a:fontRef idx="minor">
+            <a:schemeClr val="lt1"/>
+          </a:fontRef>
+        </p:style>
+        <p:txBody>
+          <a:bodyPr wrap="square" rtlCol="0" anchor="ctr">
+            <a:normAutofit fontScale="85000" lnSpcReduction="10000"/>
+          </a:bodyPr>
+          <a:lstStyle/>
+          <a:p>
+            <a:pPr algn="ctr">
+              <a:defRPr sz="1100" b="0">
+                <a:solidFill>
+                  <a:srgbClr val="141414"/>
+                </a:solidFill>
+              </a:defRPr>
+            </a:pPr>
+            <a:r>
+              <a:rPr dirty="0"/>
+              <a:t>Modular</a:t>
+            </a:r>
+            <a:br>
+              <a:rPr dirty="0"/>
+            </a:br>
+            <a:r>
+              <a:rPr dirty="0"/>
+              <a:t>Each stage can be replayed independently</a:t>
+            </a:r>
+            <a:endParaRPr lang="fr-FR" dirty="0"/>
+          </a:p>
+          <a:p>
+            <a:pPr algn="ctr">
+              <a:defRPr sz="1100" b="0">
+                <a:solidFill>
+                  <a:srgbClr val="141414"/>
+                </a:solidFill>
+              </a:defRPr>
+            </a:pPr>
+            <a:br>
+              <a:rPr dirty="0"/>
+            </a:br>
+            <a:r>
+              <a:rPr dirty="0"/>
+              <a:t>--skip-ingestion, --skip-chunking</a:t>
+            </a:r>
+          </a:p>
+        </p:txBody>
+      </p:sp>
+      <p:sp>
+        <p:nvSpPr>
+          <p:cNvPr id="17" name="Rounded Rectangle 16"/>
+          <p:cNvSpPr/>
+          <p:nvPr/>
+        </p:nvSpPr>
+        <p:spPr>
+          <a:xfrm>
+            <a:off x="3311999" y="2196000"/>
+            <a:ext cx="2376000" cy="756000"/>
+          </a:xfrm>
+          <a:prstGeom prst="roundRect">
+            <a:avLst/>
+          </a:prstGeom>
+          <a:solidFill>
+            <a:srgbClr val="F5F7FA"/>
+          </a:solidFill>
+          <a:ln w="15240">
+            <a:solidFill>
+              <a:srgbClr val="5C6069"/>
+            </a:solidFill>
+          </a:ln>
+        </p:spPr>
+        <p:style>
+          <a:lnRef idx="1">
+            <a:schemeClr val="accent1"/>
+          </a:lnRef>
+          <a:fillRef idx="3">
+            <a:schemeClr val="accent1"/>
+          </a:fillRef>
+          <a:effectRef idx="2">
+            <a:schemeClr val="accent1"/>
+          </a:effectRef>
+          <a:fontRef idx="minor">
+            <a:schemeClr val="lt1"/>
+          </a:fontRef>
+        </p:style>
+        <p:txBody>
+          <a:bodyPr wrap="square" rtlCol="0" anchor="ctr">
+            <a:normAutofit fontScale="92500" lnSpcReduction="10000"/>
+          </a:bodyPr>
+          <a:lstStyle/>
+          <a:p>
+            <a:pPr algn="ctr">
+              <a:defRPr sz="1100" b="0">
+                <a:solidFill>
+                  <a:srgbClr val="141414"/>
+                </a:solidFill>
+              </a:defRPr>
+            </a:pPr>
+            <a:r>
+              <a:rPr dirty="0"/>
+              <a:t>Traceable</a:t>
+            </a:r>
+            <a:endParaRPr lang="fr-FR" dirty="0"/>
+          </a:p>
+          <a:p>
+            <a:pPr algn="ctr">
+              <a:defRPr sz="1100" b="0">
+                <a:solidFill>
+                  <a:srgbClr val="141414"/>
+                </a:solidFill>
+              </a:defRPr>
+            </a:pPr>
+            <a:br>
+              <a:rPr dirty="0"/>
+            </a:br>
+            <a:r>
+              <a:rPr dirty="0"/>
+              <a:t>Every final card keeps source metadata</a:t>
+            </a:r>
+            <a:br>
+              <a:rPr dirty="0"/>
+            </a:br>
+            <a:r>
+              <a:rPr dirty="0"/>
+              <a:t>repo, issue, file path, URL</a:t>
+            </a:r>
+          </a:p>
+        </p:txBody>
+      </p:sp>
+      <p:sp>
+        <p:nvSpPr>
+          <p:cNvPr id="18" name="Rounded Rectangle 17"/>
+          <p:cNvSpPr/>
+          <p:nvPr/>
+        </p:nvSpPr>
+        <p:spPr>
+          <a:xfrm>
+            <a:off x="6192000" y="2196000"/>
+            <a:ext cx="2376000" cy="756000"/>
+          </a:xfrm>
+          <a:prstGeom prst="roundRect">
+            <a:avLst/>
+          </a:prstGeom>
+          <a:solidFill>
+            <a:srgbClr val="F5F7FA"/>
+          </a:solidFill>
+          <a:ln w="15240">
+            <a:solidFill>
+              <a:srgbClr val="5C6069"/>
+            </a:solidFill>
+          </a:ln>
+        </p:spPr>
+        <p:style>
+          <a:lnRef idx="1">
+            <a:schemeClr val="accent1"/>
+          </a:lnRef>
+          <a:fillRef idx="3">
+            <a:schemeClr val="accent1"/>
+          </a:fillRef>
+          <a:effectRef idx="2">
+            <a:schemeClr val="accent1"/>
+          </a:effectRef>
+          <a:fontRef idx="minor">
+            <a:schemeClr val="lt1"/>
+          </a:fontRef>
+        </p:style>
+        <p:txBody>
+          <a:bodyPr wrap="square" rtlCol="0" anchor="ctr">
+            <a:normAutofit/>
+          </a:bodyPr>
+          <a:lstStyle/>
+          <a:p>
+            <a:pPr algn="ctr">
+              <a:defRPr sz="1100" b="0">
+                <a:solidFill>
+                  <a:srgbClr val="141414"/>
+                </a:solidFill>
+              </a:defRPr>
+            </a:pPr>
+            <a:r>
+              <a:rPr dirty="0"/>
+              <a:t>Production-ready</a:t>
+            </a:r>
+            <a:br>
+              <a:rPr dirty="0"/>
+            </a:br>
+            <a:r>
+              <a:rPr dirty="0"/>
+              <a:t>Schema gates, upload IDs, retries,</a:t>
+            </a:r>
+            <a:br>
+              <a:rPr dirty="0"/>
+            </a:br>
+            <a:r>
+              <a:rPr dirty="0"/>
+              <a:t>Alfred/</a:t>
+            </a:r>
+            <a:r>
+              <a:rPr dirty="0" err="1"/>
+              <a:t>NovaX</a:t>
+            </a:r>
+            <a:r>
+              <a:rPr dirty="0"/>
+              <a:t> safeguards</a:t>
+            </a:r>
+          </a:p>
+        </p:txBody>
+      </p:sp>
+      <p:sp>
+        <p:nvSpPr>
+          <p:cNvPr id="19" name="Rounded Rectangle 3"/>
           <p:cNvSpPr/>
           <p:nvPr/>
         </p:nvSpPr>
@@ -4592,7 +5193,7 @@
         </p:style>
         <p:txBody>
           <a:bodyPr wrap="square" rtlCol="0" anchor="ctr">
-            <a:normAutofit/>
+            <a:normAutofit fontScale="85000" lnSpcReduction="20000"/>
           </a:bodyPr>
           <a:lstStyle/>
           <a:p>
@@ -4619,7 +5220,7 @@
       </p:sp>
       <p:sp>
         <p:nvSpPr>
-          <p:cNvPr id="5" name="Rounded Rectangle 4"/>
+          <p:cNvPr id="20" name="Rounded Rectangle 4"/>
           <p:cNvSpPr/>
           <p:nvPr/>
         </p:nvSpPr>
@@ -4656,7 +5257,7 @@
         </p:style>
         <p:txBody>
           <a:bodyPr wrap="square" rtlCol="0" anchor="ctr">
-            <a:normAutofit/>
+            <a:normAutofit fontScale="85000" lnSpcReduction="20000"/>
           </a:bodyPr>
           <a:lstStyle/>
           <a:p>
@@ -4683,7 +5284,7 @@
       </p:sp>
       <p:sp>
         <p:nvSpPr>
-          <p:cNvPr id="6" name="Rounded Rectangle 5"/>
+          <p:cNvPr id="21" name="Rounded Rectangle 5"/>
           <p:cNvSpPr/>
           <p:nvPr/>
         </p:nvSpPr>
@@ -4743,7 +5344,7 @@
       </p:sp>
       <p:sp>
         <p:nvSpPr>
-          <p:cNvPr id="7" name="Rounded Rectangle 6"/>
+          <p:cNvPr id="22" name="Rounded Rectangle 6"/>
           <p:cNvSpPr/>
           <p:nvPr/>
         </p:nvSpPr>
@@ -4803,7 +5404,7 @@
       </p:sp>
       <p:sp>
         <p:nvSpPr>
-          <p:cNvPr id="8" name="Rounded Rectangle 7"/>
+          <p:cNvPr id="23" name="Rounded Rectangle 7"/>
           <p:cNvSpPr/>
           <p:nvPr/>
         </p:nvSpPr>
@@ -4863,7 +5464,7 @@
       </p:sp>
       <p:sp>
         <p:nvSpPr>
-          <p:cNvPr id="9" name="Rounded Rectangle 8"/>
+          <p:cNvPr id="24" name="Rounded Rectangle 8"/>
           <p:cNvSpPr/>
           <p:nvPr/>
         </p:nvSpPr>
@@ -4923,7 +5524,7 @@
       </p:sp>
       <p:cxnSp>
         <p:nvCxnSpPr>
-          <p:cNvPr id="10" name="Connector 9"/>
+          <p:cNvPr id="25" name="Connector 9"/>
           <p:cNvCxnSpPr/>
           <p:nvPr/>
         </p:nvCxnSpPr>
@@ -4958,7 +5559,7 @@
       </p:cxnSp>
       <p:cxnSp>
         <p:nvCxnSpPr>
-          <p:cNvPr id="11" name="Connector 10"/>
+          <p:cNvPr id="26" name="Connector 10"/>
           <p:cNvCxnSpPr/>
           <p:nvPr/>
         </p:nvCxnSpPr>
@@ -4993,7 +5594,7 @@
       </p:cxnSp>
       <p:cxnSp>
         <p:nvCxnSpPr>
-          <p:cNvPr id="12" name="Connector 11"/>
+          <p:cNvPr id="27" name="Connector 11"/>
           <p:cNvCxnSpPr/>
           <p:nvPr/>
         </p:nvCxnSpPr>
@@ -5028,7 +5629,7 @@
       </p:cxnSp>
       <p:cxnSp>
         <p:nvCxnSpPr>
-          <p:cNvPr id="13" name="Connector 12"/>
+          <p:cNvPr id="28" name="Connector 12"/>
           <p:cNvCxnSpPr/>
           <p:nvPr/>
         </p:nvCxnSpPr>
@@ -5063,7 +5664,7 @@
       </p:cxnSp>
       <p:cxnSp>
         <p:nvCxnSpPr>
-          <p:cNvPr id="14" name="Connector 13"/>
+          <p:cNvPr id="29" name="Connector 13"/>
           <p:cNvCxnSpPr/>
           <p:nvPr/>
         </p:nvCxnSpPr>
@@ -5096,233 +5697,6 @@
           </a:fontRef>
         </p:style>
       </p:cxnSp>
-      <p:sp>
-        <p:nvSpPr>
-          <p:cNvPr id="15" name="TextBox 14"/>
-          <p:cNvSpPr txBox="1"/>
-          <p:nvPr/>
-        </p:nvSpPr>
-        <p:spPr>
-          <a:xfrm>
-            <a:off x="432000" y="1835999"/>
-            <a:ext cx="8100000" cy="288000"/>
-          </a:xfrm>
-          <a:prstGeom prst="rect">
-            <a:avLst/>
-          </a:prstGeom>
-          <a:noFill/>
-        </p:spPr>
-        <p:txBody>
-          <a:bodyPr wrap="square">
-            <a:normAutofit/>
-          </a:bodyPr>
-          <a:lstStyle/>
-          <a:p>
-            <a:pPr algn="l">
-              <a:defRPr sz="1600" b="1">
-                <a:solidFill>
-                  <a:srgbClr val="1A237E"/>
-                </a:solidFill>
-              </a:defRPr>
-            </a:pPr>
-            <a:r>
-              <a:t>What the audience must understand first</a:t>
-            </a:r>
-          </a:p>
-        </p:txBody>
-      </p:sp>
-      <p:sp>
-        <p:nvSpPr>
-          <p:cNvPr id="16" name="Rounded Rectangle 15"/>
-          <p:cNvSpPr/>
-          <p:nvPr/>
-        </p:nvSpPr>
-        <p:spPr>
-          <a:xfrm>
-            <a:off x="432000" y="2196000"/>
-            <a:ext cx="2376000" cy="756000"/>
-          </a:xfrm>
-          <a:prstGeom prst="roundRect">
-            <a:avLst/>
-          </a:prstGeom>
-          <a:solidFill>
-            <a:srgbClr val="F5F7FA"/>
-          </a:solidFill>
-          <a:ln w="15240">
-            <a:solidFill>
-              <a:srgbClr val="5C6069"/>
-            </a:solidFill>
-          </a:ln>
-        </p:spPr>
-        <p:style>
-          <a:lnRef idx="1">
-            <a:schemeClr val="accent1"/>
-          </a:lnRef>
-          <a:fillRef idx="3">
-            <a:schemeClr val="accent1"/>
-          </a:fillRef>
-          <a:effectRef idx="2">
-            <a:schemeClr val="accent1"/>
-          </a:effectRef>
-          <a:fontRef idx="minor">
-            <a:schemeClr val="lt1"/>
-          </a:fontRef>
-        </p:style>
-        <p:txBody>
-          <a:bodyPr wrap="square" rtlCol="0" anchor="ctr">
-            <a:normAutofit/>
-          </a:bodyPr>
-          <a:lstStyle/>
-          <a:p>
-            <a:pPr algn="ctr">
-              <a:defRPr sz="1100" b="0">
-                <a:solidFill>
-                  <a:srgbClr val="141414"/>
-                </a:solidFill>
-              </a:defRPr>
-            </a:pPr>
-            <a:r>
-              <a:t>Modular</a:t>
-            </a:r>
-            <a:br/>
-            <a:r>
-              <a:t>Each stage can be replayed independently</a:t>
-            </a:r>
-            <a:br/>
-            <a:r>
-              <a:t>--skip-ingestion, --skip-chunking</a:t>
-            </a:r>
-          </a:p>
-        </p:txBody>
-      </p:sp>
-      <p:sp>
-        <p:nvSpPr>
-          <p:cNvPr id="17" name="Rounded Rectangle 16"/>
-          <p:cNvSpPr/>
-          <p:nvPr/>
-        </p:nvSpPr>
-        <p:spPr>
-          <a:xfrm>
-            <a:off x="3311999" y="2196000"/>
-            <a:ext cx="2376000" cy="756000"/>
-          </a:xfrm>
-          <a:prstGeom prst="roundRect">
-            <a:avLst/>
-          </a:prstGeom>
-          <a:solidFill>
-            <a:srgbClr val="F5F7FA"/>
-          </a:solidFill>
-          <a:ln w="15240">
-            <a:solidFill>
-              <a:srgbClr val="5C6069"/>
-            </a:solidFill>
-          </a:ln>
-        </p:spPr>
-        <p:style>
-          <a:lnRef idx="1">
-            <a:schemeClr val="accent1"/>
-          </a:lnRef>
-          <a:fillRef idx="3">
-            <a:schemeClr val="accent1"/>
-          </a:fillRef>
-          <a:effectRef idx="2">
-            <a:schemeClr val="accent1"/>
-          </a:effectRef>
-          <a:fontRef idx="minor">
-            <a:schemeClr val="lt1"/>
-          </a:fontRef>
-        </p:style>
-        <p:txBody>
-          <a:bodyPr wrap="square" rtlCol="0" anchor="ctr">
-            <a:normAutofit/>
-          </a:bodyPr>
-          <a:lstStyle/>
-          <a:p>
-            <a:pPr algn="ctr">
-              <a:defRPr sz="1100" b="0">
-                <a:solidFill>
-                  <a:srgbClr val="141414"/>
-                </a:solidFill>
-              </a:defRPr>
-            </a:pPr>
-            <a:r>
-              <a:t>Traceable</a:t>
-            </a:r>
-            <a:br/>
-            <a:r>
-              <a:t>Every final card keeps source metadata</a:t>
-            </a:r>
-            <a:br/>
-            <a:r>
-              <a:t>repo, issue, file path, URL</a:t>
-            </a:r>
-          </a:p>
-        </p:txBody>
-      </p:sp>
-      <p:sp>
-        <p:nvSpPr>
-          <p:cNvPr id="18" name="Rounded Rectangle 17"/>
-          <p:cNvSpPr/>
-          <p:nvPr/>
-        </p:nvSpPr>
-        <p:spPr>
-          <a:xfrm>
-            <a:off x="6192000" y="2196000"/>
-            <a:ext cx="2376000" cy="756000"/>
-          </a:xfrm>
-          <a:prstGeom prst="roundRect">
-            <a:avLst/>
-          </a:prstGeom>
-          <a:solidFill>
-            <a:srgbClr val="F5F7FA"/>
-          </a:solidFill>
-          <a:ln w="15240">
-            <a:solidFill>
-              <a:srgbClr val="5C6069"/>
-            </a:solidFill>
-          </a:ln>
-        </p:spPr>
-        <p:style>
-          <a:lnRef idx="1">
-            <a:schemeClr val="accent1"/>
-          </a:lnRef>
-          <a:fillRef idx="3">
-            <a:schemeClr val="accent1"/>
-          </a:fillRef>
-          <a:effectRef idx="2">
-            <a:schemeClr val="accent1"/>
-          </a:effectRef>
-          <a:fontRef idx="minor">
-            <a:schemeClr val="lt1"/>
-          </a:fontRef>
-        </p:style>
-        <p:txBody>
-          <a:bodyPr wrap="square" rtlCol="0" anchor="ctr">
-            <a:normAutofit/>
-          </a:bodyPr>
-          <a:lstStyle/>
-          <a:p>
-            <a:pPr algn="ctr">
-              <a:defRPr sz="1100" b="0">
-                <a:solidFill>
-                  <a:srgbClr val="141414"/>
-                </a:solidFill>
-              </a:defRPr>
-            </a:pPr>
-            <a:r>
-              <a:t>Production-ready</a:t>
-            </a:r>
-            <a:br/>
-            <a:r>
-              <a:t>Schema gates, upload IDs, retries,</a:t>
-            </a:r>
-            <a:br/>
-            <a:r>
-              <a:t>Alfred/NovaX safeguards</a:t>
-            </a:r>
-          </a:p>
-        </p:txBody>
-      </p:sp>
     </p:spTree>
   </p:cSld>
   <p:clrMapOvr>
@@ -11107,6 +11481,7 @@
               </a:defRPr>
             </a:pPr>
             <a:r>
+              <a:rPr dirty="0"/>
               <a:t>1. Executive Summary</a:t>
             </a:r>
           </a:p>
@@ -11122,6 +11497,7 @@
               </a:defRPr>
             </a:pPr>
             <a:r>
+              <a:rPr dirty="0"/>
               <a:t>2. Context &amp; Business Need</a:t>
             </a:r>
           </a:p>
@@ -11137,6 +11513,7 @@
               </a:defRPr>
             </a:pPr>
             <a:r>
+              <a:rPr dirty="0"/>
               <a:t>3. Architecture Overview (+ Master Diagram)</a:t>
             </a:r>
           </a:p>
@@ -11152,6 +11529,7 @@
               </a:defRPr>
             </a:pPr>
             <a:r>
+              <a:rPr dirty="0"/>
               <a:t>4. End-to-End Pipeline — 23 Steps</a:t>
             </a:r>
           </a:p>
@@ -11167,6 +11545,7 @@
               </a:defRPr>
             </a:pPr>
             <a:r>
+              <a:rPr dirty="0"/>
               <a:t>5. Configuration &amp; Execution</a:t>
             </a:r>
           </a:p>
@@ -11182,6 +11561,7 @@
               </a:defRPr>
             </a:pPr>
             <a:r>
+              <a:rPr dirty="0"/>
               <a:t>6. Preprocessing Deep Dive (Cleaning, Enrichment, Similarity)</a:t>
             </a:r>
           </a:p>
@@ -11197,6 +11577,7 @@
               </a:defRPr>
             </a:pPr>
             <a:r>
+              <a:rPr dirty="0"/>
               <a:t>7. ALFRED Vision Integration (PDF + Images)</a:t>
             </a:r>
           </a:p>
@@ -11212,6 +11593,7 @@
               </a:defRPr>
             </a:pPr>
             <a:r>
+              <a:rPr dirty="0"/>
               <a:t>8. Delivery &amp; Upload to Knowledge Base</a:t>
             </a:r>
           </a:p>
@@ -11227,6 +11609,7 @@
               </a:defRPr>
             </a:pPr>
             <a:r>
+              <a:rPr dirty="0"/>
               <a:t>9. Quality Gates &amp; Validation</a:t>
             </a:r>
           </a:p>
@@ -11242,6 +11625,7 @@
               </a:defRPr>
             </a:pPr>
             <a:r>
+              <a:rPr dirty="0"/>
               <a:t>10. Value Proposition &amp; Impact</a:t>
             </a:r>
           </a:p>
@@ -11257,6 +11641,7 @@
               </a:defRPr>
             </a:pPr>
             <a:r>
+              <a:rPr dirty="0"/>
               <a:t>11. Operational Guide (Troubleshooting, Best Practices)</a:t>
             </a:r>
           </a:p>
@@ -11272,6 +11657,7 @@
               </a:defRPr>
             </a:pPr>
             <a:r>
+              <a:rPr dirty="0"/>
               <a:t>12. Live Demo &amp; Hands-On</a:t>
             </a:r>
           </a:p>
@@ -11287,6 +11673,7 @@
               </a:defRPr>
             </a:pPr>
             <a:r>
+              <a:rPr dirty="0"/>
               <a:t>13. Conclusion &amp; Next Steps</a:t>
             </a:r>
           </a:p>
@@ -17981,7 +18368,7 @@
         </p:spPr>
         <p:txBody>
           <a:bodyPr wrap="square">
-            <a:normAutofit/>
+            <a:normAutofit fontScale="92500" lnSpcReduction="10000"/>
           </a:bodyPr>
           <a:lstStyle/>
           <a:p>
@@ -19398,7 +19785,7 @@
         </p:spPr>
         <p:txBody>
           <a:bodyPr wrap="square">
-            <a:normAutofit/>
+            <a:normAutofit fontScale="92500" lnSpcReduction="10000"/>
           </a:bodyPr>
           <a:lstStyle/>
           <a:p>
@@ -23130,7 +23517,7 @@
         </p:spPr>
         <p:txBody>
           <a:bodyPr wrap="square">
-            <a:normAutofit/>
+            <a:normAutofit fontScale="92500" lnSpcReduction="10000"/>
           </a:bodyPr>
           <a:lstStyle/>
           <a:p>
@@ -25072,7 +25459,7 @@
         </p:spPr>
         <p:txBody>
           <a:bodyPr wrap="square">
-            <a:normAutofit/>
+            <a:normAutofit fontScale="92500" lnSpcReduction="10000"/>
           </a:bodyPr>
           <a:lstStyle/>
           <a:p>
@@ -28693,7 +29080,7 @@
         </p:spPr>
         <p:txBody>
           <a:bodyPr wrap="square">
-            <a:normAutofit/>
+            <a:normAutofit fontScale="92500" lnSpcReduction="10000"/>
           </a:bodyPr>
           <a:lstStyle/>
           <a:p>
@@ -28763,7 +29150,7 @@
         </p:spPr>
         <p:txBody>
           <a:bodyPr wrap="square">
-            <a:normAutofit/>
+            <a:normAutofit fontScale="47500" lnSpcReduction="20000"/>
           </a:bodyPr>
           <a:lstStyle/>
           <a:p>
@@ -28890,7 +29277,7 @@
         </p:spPr>
         <p:txBody>
           <a:bodyPr wrap="square">
-            <a:normAutofit/>
+            <a:normAutofit fontScale="47500" lnSpcReduction="20000"/>
           </a:bodyPr>
           <a:lstStyle/>
           <a:p>
@@ -28925,7 +29312,7 @@
         </p:spPr>
         <p:txBody>
           <a:bodyPr wrap="square">
-            <a:normAutofit/>
+            <a:normAutofit fontScale="47500" lnSpcReduction="20000"/>
           </a:bodyPr>
           <a:lstStyle/>
           <a:p>
@@ -29052,7 +29439,7 @@
         </p:spPr>
         <p:txBody>
           <a:bodyPr wrap="square">
-            <a:normAutofit/>
+            <a:normAutofit fontScale="47500" lnSpcReduction="20000"/>
           </a:bodyPr>
           <a:lstStyle/>
           <a:p>
@@ -29087,7 +29474,7 @@
         </p:spPr>
         <p:txBody>
           <a:bodyPr wrap="square">
-            <a:normAutofit/>
+            <a:normAutofit fontScale="47500" lnSpcReduction="20000"/>
           </a:bodyPr>
           <a:lstStyle/>
           <a:p>
@@ -29214,7 +29601,7 @@
         </p:spPr>
         <p:txBody>
           <a:bodyPr wrap="square">
-            <a:normAutofit/>
+            <a:normAutofit fontScale="47500" lnSpcReduction="20000"/>
           </a:bodyPr>
           <a:lstStyle/>
           <a:p>
@@ -29377,7 +29764,7 @@
         </p:spPr>
         <p:txBody>
           <a:bodyPr wrap="square">
-            <a:normAutofit/>
+            <a:normAutofit fontScale="92500"/>
           </a:bodyPr>
           <a:lstStyle/>
           <a:p>

</xml_diff>